<commit_message>
nova shema, fixani tokeni, popravlen ui za telefon (!important pusti)
</commit_message>
<xml_diff>
--- a/skillboost/_PROMOCIJA/SkillBoostPredstavitev.pptx
+++ b/skillboost/_PROMOCIJA/SkillBoostPredstavitev.pptx
@@ -230,7 +230,7 @@
           <a:p>
             <a:fld id="{1CA5457B-CDAE-4DEB-AEC8-C82DE2312E37}" type="datetimeFigureOut">
               <a:rPr lang="en-US" smtClean="0"/>
-              <a:t>6/7/2026</a:t>
+              <a:t>6/8/2026</a:t>
             </a:fld>
             <a:endParaRPr lang="en-US" dirty="0"/>
           </a:p>
@@ -407,7 +407,7 @@
           <a:p>
             <a:fld id="{090B78EA-28CE-41D8-9043-90E391E5F567}" type="datetimeFigureOut">
               <a:rPr lang="en-US" noProof="0" smtClean="0"/>
-              <a:t>6/7/2026</a:t>
+              <a:t>6/8/2026</a:t>
             </a:fld>
             <a:endParaRPr lang="en-US" noProof="0" dirty="0"/>
           </a:p>
@@ -25963,10 +25963,10 @@
       </p:sp>
       <p:pic>
         <p:nvPicPr>
-          <p:cNvPr id="5" name="Picture 4">
+          <p:cNvPr id="6" name="Slika 5">
             <a:extLst>
               <a:ext uri="{FF2B5EF4-FFF2-40B4-BE49-F238E27FC236}">
-                <a16:creationId xmlns:a16="http://schemas.microsoft.com/office/drawing/2014/main" id="{E33B4081-4A0C-ABCB-79D0-F8E552DE9A68}"/>
+                <a16:creationId xmlns:a16="http://schemas.microsoft.com/office/drawing/2014/main" id="{1B855EFA-708B-09EF-4E6D-3598654CA6C9}"/>
               </a:ext>
             </a:extLst>
           </p:cNvPr>
@@ -25983,12 +25983,42 @@
         </p:blipFill>
         <p:spPr>
           <a:xfrm>
-            <a:off x="174302" y="220166"/>
-            <a:ext cx="11843395" cy="6460034"/>
+            <a:off x="1954364" y="1078456"/>
+            <a:ext cx="8194371" cy="5466473"/>
           </a:xfrm>
           <a:prstGeom prst="rect">
             <a:avLst/>
           </a:prstGeom>
+          <a:solidFill>
+            <a:srgbClr val="FFFFFF">
+              <a:shade val="85000"/>
+            </a:srgbClr>
+          </a:solidFill>
+          <a:ln w="88900" cap="sq">
+            <a:solidFill>
+              <a:srgbClr val="FFFFFF"/>
+            </a:solidFill>
+            <a:miter lim="800000"/>
+          </a:ln>
+          <a:effectLst>
+            <a:outerShdw blurRad="55000" dist="18000" dir="5400000" algn="tl" rotWithShape="0">
+              <a:srgbClr val="000000">
+                <a:alpha val="40000"/>
+              </a:srgbClr>
+            </a:outerShdw>
+          </a:effectLst>
+          <a:scene3d>
+            <a:camera prst="orthographicFront"/>
+            <a:lightRig rig="twoPt" dir="t">
+              <a:rot lat="0" lon="0" rev="7200000"/>
+            </a:lightRig>
+          </a:scene3d>
+          <a:sp3d>
+            <a:bevelT w="25400" h="19050"/>
+            <a:contourClr>
+              <a:srgbClr val="FFFFFF"/>
+            </a:contourClr>
+          </a:sp3d>
         </p:spPr>
       </p:pic>
     </p:spTree>
@@ -27293,6 +27323,23 @@
 </file>
 
 <file path=customXml/item1.xml><?xml version="1.0" encoding="utf-8"?>
+<p:properties xmlns:p="http://schemas.microsoft.com/office/2006/metadata/properties" xmlns:xsi="http://www.w3.org/2001/XMLSchema-instance" xmlns:pc="http://schemas.microsoft.com/office/infopath/2007/PartnerControls">
+  <documentManagement>
+    <MediaServiceKeyPoints xmlns="71af3243-3dd4-4a8d-8c0d-dd76da1f02a5" xsi:nil="true"/>
+  </documentManagement>
+</p:properties>
+</file>
+
+<file path=customXml/item2.xml><?xml version="1.0" encoding="utf-8"?>
+<?mso-contentType ?>
+<FormTemplates xmlns="http://schemas.microsoft.com/sharepoint/v3/contenttype/forms">
+  <Display>DocumentLibraryForm</Display>
+  <Edit>DocumentLibraryForm</Edit>
+  <New>DocumentLibraryForm</New>
+</FormTemplates>
+</file>
+
+<file path=customXml/item3.xml><?xml version="1.0" encoding="utf-8"?>
 <ct:contentTypeSchema xmlns:ct="http://schemas.microsoft.com/office/2006/metadata/contentType" xmlns:ma="http://schemas.microsoft.com/office/2006/metadata/properties/metaAttributes" ct:_="" ma:_="" ma:contentTypeName="Document" ma:contentTypeID="0x01010079F111ED35F8CC479449609E8A0923A6" ma:contentTypeVersion="11" ma:contentTypeDescription="Create a new document." ma:contentTypeScope="" ma:versionID="96291512c1ee715ab617f4c07df79fc1">
   <xsd:schema xmlns:xsd="http://www.w3.org/2001/XMLSchema" xmlns:xs="http://www.w3.org/2001/XMLSchema" xmlns:p="http://schemas.microsoft.com/office/2006/metadata/properties" xmlns:ns2="71af3243-3dd4-4a8d-8c0d-dd76da1f02a5" xmlns:ns3="16c05727-aa75-4e4a-9b5f-8a80a1165891" targetNamespace="http://schemas.microsoft.com/office/2006/metadata/properties" ma:root="true" ma:fieldsID="8256c27c40ca5c40ce1cf6c44f0205df" ns2:_="" ns3:_="">
     <xsd:import namespace="71af3243-3dd4-4a8d-8c0d-dd76da1f02a5"/>
@@ -27503,24 +27550,25 @@
 </ct:contentTypeSchema>
 </file>
 
-<file path=customXml/item2.xml><?xml version="1.0" encoding="utf-8"?>
-<?mso-contentType ?>
-<FormTemplates xmlns="http://schemas.microsoft.com/sharepoint/v3/contenttype/forms">
-  <Display>DocumentLibraryForm</Display>
-  <Edit>DocumentLibraryForm</Edit>
-  <New>DocumentLibraryForm</New>
-</FormTemplates>
+<file path=customXml/itemProps1.xml><?xml version="1.0" encoding="utf-8"?>
+<ds:datastoreItem xmlns:ds="http://schemas.openxmlformats.org/officeDocument/2006/customXml" ds:itemID="{F5757914-1161-4661-9696-421FD6935CDD}">
+  <ds:schemaRefs>
+    <ds:schemaRef ds:uri="http://schemas.microsoft.com/office/2006/metadata/properties"/>
+    <ds:schemaRef ds:uri="http://schemas.microsoft.com/office/infopath/2007/PartnerControls"/>
+    <ds:schemaRef ds:uri="71af3243-3dd4-4a8d-8c0d-dd76da1f02a5"/>
+  </ds:schemaRefs>
+</ds:datastoreItem>
 </file>
 
-<file path=customXml/item3.xml><?xml version="1.0" encoding="utf-8"?>
-<p:properties xmlns:p="http://schemas.microsoft.com/office/2006/metadata/properties" xmlns:xsi="http://www.w3.org/2001/XMLSchema-instance" xmlns:pc="http://schemas.microsoft.com/office/infopath/2007/PartnerControls">
-  <documentManagement>
-    <MediaServiceKeyPoints xmlns="71af3243-3dd4-4a8d-8c0d-dd76da1f02a5" xsi:nil="true"/>
-  </documentManagement>
-</p:properties>
+<file path=customXml/itemProps2.xml><?xml version="1.0" encoding="utf-8"?>
+<ds:datastoreItem xmlns:ds="http://schemas.openxmlformats.org/officeDocument/2006/customXml" ds:itemID="{5B26E0C9-B2AA-42E6-97B6-E1B7D9EAF129}">
+  <ds:schemaRefs>
+    <ds:schemaRef ds:uri="http://schemas.microsoft.com/sharepoint/v3/contenttype/forms"/>
+  </ds:schemaRefs>
+</ds:datastoreItem>
 </file>
 
-<file path=customXml/itemProps1.xml><?xml version="1.0" encoding="utf-8"?>
+<file path=customXml/itemProps3.xml><?xml version="1.0" encoding="utf-8"?>
 <ds:datastoreItem xmlns:ds="http://schemas.openxmlformats.org/officeDocument/2006/customXml" ds:itemID="{4C103400-4A22-4E35-B588-4C4D42638959}">
   <ds:schemaRefs>
     <ds:schemaRef ds:uri="http://schemas.microsoft.com/office/2006/metadata/contentType"/>
@@ -27537,22 +27585,4 @@
     <ds:schemaRef ds:uri="http://schemas.microsoft.com/internal/obd"/>
   </ds:schemaRefs>
 </ds:datastoreItem>
-</file>
-
-<file path=customXml/itemProps2.xml><?xml version="1.0" encoding="utf-8"?>
-<ds:datastoreItem xmlns:ds="http://schemas.openxmlformats.org/officeDocument/2006/customXml" ds:itemID="{5B26E0C9-B2AA-42E6-97B6-E1B7D9EAF129}">
-  <ds:schemaRefs>
-    <ds:schemaRef ds:uri="http://schemas.microsoft.com/sharepoint/v3/contenttype/forms"/>
-  </ds:schemaRefs>
-</ds:datastoreItem>
-</file>
-
-<file path=customXml/itemProps3.xml><?xml version="1.0" encoding="utf-8"?>
-<ds:datastoreItem xmlns:ds="http://schemas.openxmlformats.org/officeDocument/2006/customXml" ds:itemID="{F5757914-1161-4661-9696-421FD6935CDD}">
-  <ds:schemaRefs>
-    <ds:schemaRef ds:uri="http://schemas.microsoft.com/office/2006/metadata/properties"/>
-    <ds:schemaRef ds:uri="http://schemas.microsoft.com/office/infopath/2007/PartnerControls"/>
-    <ds:schemaRef ds:uri="71af3243-3dd4-4a8d-8c0d-dd76da1f02a5"/>
-  </ds:schemaRefs>
-</ds:datastoreItem>
 </file>
</xml_diff>